<commit_message>
Update portfolio metrics reference
</commit_message>
<xml_diff>
--- a/tests/report_generator/integration/references/reference_portfolio-metrics.pptx
+++ b/tests/report_generator/integration/references/reference_portfolio-metrics.pptx
@@ -17917,7 +17917,7 @@
                 <a:ea typeface="Calibri"/>
                 <a:cs typeface="Calibri"/>
               </a:rPr>
-              <a:t>The largest increase in Unit Interfacing rating was experienced by integrationtest-airflow (0.0 stars). The largest decrease in Unit Interfacing rating was experienced by integrationtest-facebookyoga (0.0 stars).</a:t>
+              <a:t>The largest increase in Unit Interfacing rating was experienced by integrationtest-airflow (0.0 stars). The largest decrease in Unit Interfacing rating was experienced by integrationtest-facebookyoga (-0.0 stars).</a:t>
             </a:r>
           </a:p>
         </p:txBody>
@@ -21103,7 +21103,7 @@
                 <a:ea typeface="Calibri"/>
                 <a:cs typeface="Calibri"/>
               </a:rPr>
-              <a:t>The largest increase in Component Independence rating was experienced by integrationtest-jruby (0.0 stars). The largest decrease in Component Independence rating was experienced by integrationtest-vscode (-0.2 stars).</a:t>
+              <a:t>The largest increase in Component Independence rating was experienced by integrationtest-jruby (0.1 stars). The largest decrease in Component Independence rating was experienced by integrationtest-vscode (-0.3 stars).</a:t>
             </a:r>
           </a:p>
         </p:txBody>
@@ -41849,7 +41849,7 @@
                 <a:ea typeface="Calibri"/>
                 <a:cs typeface="Calibri"/>
               </a:rPr>
-              <a:t>The largest increase in Duplication rating was experienced by integrationtest-bazel (0.0 stars). The largest decrease in Duplication rating was experienced by integrationtest-webpack (0.0 stars).</a:t>
+              <a:t>The largest increase in Duplication rating was experienced by integrationtest-bazel (0.1 stars). The largest decrease in Duplication rating was experienced by integrationtest-webpack (-0.1 stars).</a:t>
             </a:r>
           </a:p>
         </p:txBody>
@@ -47222,7 +47222,7 @@
                 <a:ea typeface="Calibri"/>
                 <a:cs typeface="Calibri"/>
               </a:rPr>
-              <a:t>The largest increase in Unit Size rating was experienced by integrationtest-zuul (0.0 stars). The largest decrease in Unit Size rating was experienced by integrationtest-electron (0.0 stars).</a:t>
+              <a:t>The largest increase in Unit Size rating was experienced by integrationtest-zuul (0.0 stars). The largest decrease in Unit Size rating was experienced by integrationtest-electron (-0.1 stars).</a:t>
             </a:r>
           </a:p>
         </p:txBody>
@@ -48815,7 +48815,7 @@
                 <a:ea typeface="Calibri"/>
                 <a:cs typeface="Calibri"/>
               </a:rPr>
-              <a:t>The largest increase in Unit Complexity rating was experienced by integrationtest-druid (0.0 stars). The largest decrease in Unit Complexity rating was experienced by integrationtest-facebookyoga (0.0 stars).</a:t>
+              <a:t>The largest increase in Unit Complexity rating was experienced by integrationtest-druid (0.0 stars). The largest decrease in Unit Complexity rating was experienced by integrationtest-facebookyoga (-0.1 stars).</a:t>
             </a:r>
           </a:p>
         </p:txBody>

</xml_diff>